<commit_message>
Add source citation to RBC/macrophage calreticulin slide
Co-Authored-By: Claude Opus 5.5 <noreply@anthropic.com>
Claude-Session: https://claude.ai/code/session_016zyDW6T1x7w4TWJhWZZdRw
</commit_message>
<xml_diff>
--- a/RBC_Macs_Calreticulin.pptx
+++ b/RBC_Macs_Calreticulin.pptx
@@ -5199,7 +5199,7 @@
         </p:nvSpPr>
         <p:spPr>
           <a:xfrm>
-            <a:off x="5074920" y="6236208"/>
+            <a:off x="8366760" y="4727448"/>
             <a:ext cx="109728" cy="109728"/>
           </a:xfrm>
           <a:prstGeom prst="diamond">
@@ -5245,7 +5245,7 @@
         </p:nvSpPr>
         <p:spPr>
           <a:xfrm>
-            <a:off x="5276088" y="6144768"/>
+            <a:off x="8567928" y="4636008"/>
             <a:ext cx="2377440" cy="292608"/>
           </a:xfrm>
           <a:prstGeom prst="rect">
@@ -5268,6 +5268,68 @@
                 <a:latin typeface="Arial"/>
               </a:rPr>
               <a:t>Calreticulin (“eat me”)</a:t>
+            </a:r>
+          </a:p>
+        </p:txBody>
+      </p:sp>
+      <p:sp>
+        <p:nvSpPr>
+          <p:cNvPr id="47" name="Source citation"/>
+          <p:cNvSpPr txBox="1"/>
+          <p:nvPr/>
+        </p:nvSpPr>
+        <p:spPr>
+          <a:xfrm>
+            <a:off x="1527048" y="6199632"/>
+            <a:ext cx="9144000" cy="457200"/>
+          </a:xfrm>
+          <a:prstGeom prst="rect">
+            <a:avLst/>
+          </a:prstGeom>
+          <a:noFill/>
+        </p:spPr>
+        <p:txBody>
+          <a:bodyPr wrap="square" lIns="0" rIns="0" tIns="0" bIns="0">
+            <a:spAutoFit/>
+          </a:bodyPr>
+          <a:lstStyle/>
+          <a:p>
+            <a:pPr algn="ctr"/>
+            <a:r>
+              <a:rPr sz="1100" i="0">
+                <a:solidFill>
+                  <a:srgbClr val="6B6B6B"/>
+                </a:solidFill>
+                <a:latin typeface="Arial"/>
+              </a:rPr>
+              <a:t>Adapted from: </a:t>
+            </a:r>
+            <a:r>
+              <a:rPr sz="1100" i="0">
+                <a:solidFill>
+                  <a:srgbClr val="6B6B6B"/>
+                </a:solidFill>
+                <a:latin typeface="Arial"/>
+              </a:rPr>
+              <a:t>Preclinical and clinical development of therapeutic antibodies targeting functions of CD47 in the tumor microenvironment.</a:t>
+            </a:r>
+            <a:r>
+              <a:rPr sz="1100" i="1">
+                <a:solidFill>
+                  <a:srgbClr val="6B6B6B"/>
+                </a:solidFill>
+                <a:latin typeface="Arial"/>
+              </a:rPr>
+              <a:t> Antibody Therapeutics</a:t>
+            </a:r>
+            <a:r>
+              <a:rPr sz="1100" i="0">
+                <a:solidFill>
+                  <a:srgbClr val="6B6B6B"/>
+                </a:solidFill>
+                <a:latin typeface="Arial"/>
+              </a:rPr>
+              <a:t>. 2020;3(3):179–192. doi:10.1093/abt/tbaa017</a:t>
             </a:r>
           </a:p>
         </p:txBody>

</xml_diff>